<commit_message>
arrays and clean title page of pptx
</commit_message>
<xml_diff>
--- a/topic02-understanding-class-definitions/unit-1/talk-1/a-class-definitions.pptx
+++ b/topic02-understanding-class-definitions/unit-1/talk-1/a-class-definitions.pptx
@@ -498,14 +498,14 @@
           </a:ln>
           <a:extLst>
             <a:ext uri="{909E8E84-426E-40dd-AFC4-6F175D3DCCD1}">
-              <a14:hiddenFill xmlns:a14="http://schemas.microsoft.com/office/drawing/2010/main" xmlns="">
+              <a14:hiddenFill xmlns="" xmlns:a14="http://schemas.microsoft.com/office/drawing/2010/main">
                 <a:solidFill>
                   <a:srgbClr val="FFFFFF"/>
                 </a:solidFill>
               </a14:hiddenFill>
             </a:ext>
             <a:ext uri="{FAA26D3D-D897-4be2-8F04-BA451C77F1D7}">
-              <ma14:placeholderFlag xmlns:ma14="http://schemas.microsoft.com/office/mac/drawingml/2011/main" xmlns="" val="1"/>
+              <ma14:placeholderFlag xmlns="" xmlns:ma14="http://schemas.microsoft.com/office/mac/drawingml/2011/main" val="1"/>
             </a:ext>
           </a:extLst>
         </p:spPr>
@@ -849,14 +849,14 @@
           <a:noFill/>
           <a:extLst>
             <a:ext uri="{909E8E84-426E-40dd-AFC4-6F175D3DCCD1}">
-              <a14:hiddenFill xmlns:a14="http://schemas.microsoft.com/office/drawing/2010/main" xmlns="">
+              <a14:hiddenFill xmlns="" xmlns:a14="http://schemas.microsoft.com/office/drawing/2010/main">
                 <a:solidFill>
                   <a:srgbClr val="FFFFFF"/>
                 </a:solidFill>
               </a14:hiddenFill>
             </a:ext>
             <a:ext uri="{91240B29-F687-4f45-9708-019B960494DF}">
-              <a14:hiddenLine xmlns:a14="http://schemas.microsoft.com/office/drawing/2010/main" xmlns="" w="9525">
+              <a14:hiddenLine xmlns="" xmlns:a14="http://schemas.microsoft.com/office/drawing/2010/main" w="9525">
                 <a:solidFill>
                   <a:srgbClr val="000000"/>
                 </a:solidFill>
@@ -1004,14 +1004,14 @@
           <a:noFill/>
           <a:extLst>
             <a:ext uri="{909E8E84-426E-40dd-AFC4-6F175D3DCCD1}">
-              <a14:hiddenFill xmlns:a14="http://schemas.microsoft.com/office/drawing/2010/main" xmlns="">
+              <a14:hiddenFill xmlns="" xmlns:a14="http://schemas.microsoft.com/office/drawing/2010/main">
                 <a:solidFill>
                   <a:srgbClr val="FFFFFF"/>
                 </a:solidFill>
               </a14:hiddenFill>
             </a:ext>
             <a:ext uri="{91240B29-F687-4f45-9708-019B960494DF}">
-              <a14:hiddenLine xmlns:a14="http://schemas.microsoft.com/office/drawing/2010/main" xmlns="" w="9525">
+              <a14:hiddenLine xmlns="" xmlns:a14="http://schemas.microsoft.com/office/drawing/2010/main" w="9525">
                 <a:solidFill>
                   <a:srgbClr val="000000"/>
                 </a:solidFill>
@@ -1159,14 +1159,14 @@
           <a:noFill/>
           <a:extLst>
             <a:ext uri="{909E8E84-426E-40dd-AFC4-6F175D3DCCD1}">
-              <a14:hiddenFill xmlns:a14="http://schemas.microsoft.com/office/drawing/2010/main" xmlns="">
+              <a14:hiddenFill xmlns="" xmlns:a14="http://schemas.microsoft.com/office/drawing/2010/main">
                 <a:solidFill>
                   <a:srgbClr val="FFFFFF"/>
                 </a:solidFill>
               </a14:hiddenFill>
             </a:ext>
             <a:ext uri="{91240B29-F687-4f45-9708-019B960494DF}">
-              <a14:hiddenLine xmlns:a14="http://schemas.microsoft.com/office/drawing/2010/main" xmlns="" w="9525">
+              <a14:hiddenLine xmlns="" xmlns:a14="http://schemas.microsoft.com/office/drawing/2010/main" w="9525">
                 <a:solidFill>
                   <a:srgbClr val="000000"/>
                 </a:solidFill>
@@ -1338,7 +1338,7 @@
         <p:spPr>
           <a:extLst>
             <a:ext uri="{FAA26D3D-D897-4be2-8F04-BA451C77F1D7}">
-              <ma14:placeholderFlag xmlns:ma14="http://schemas.microsoft.com/office/mac/drawingml/2011/main" xmlns="" val="1"/>
+              <ma14:placeholderFlag xmlns="" xmlns:ma14="http://schemas.microsoft.com/office/mac/drawingml/2011/main" val="1"/>
             </a:ext>
           </a:extLst>
         </p:spPr>
@@ -1400,14 +1400,14 @@
           <a:noFill/>
           <a:extLst>
             <a:ext uri="{909E8E84-426E-40dd-AFC4-6F175D3DCCD1}">
-              <a14:hiddenFill xmlns:a14="http://schemas.microsoft.com/office/drawing/2010/main" xmlns="">
+              <a14:hiddenFill xmlns="" xmlns:a14="http://schemas.microsoft.com/office/drawing/2010/main">
                 <a:solidFill>
                   <a:srgbClr val="FFFFFF"/>
                 </a:solidFill>
               </a14:hiddenFill>
             </a:ext>
             <a:ext uri="{91240B29-F687-4f45-9708-019B960494DF}">
-              <a14:hiddenLine xmlns:a14="http://schemas.microsoft.com/office/drawing/2010/main" xmlns="" w="9525">
+              <a14:hiddenLine xmlns="" xmlns:a14="http://schemas.microsoft.com/office/drawing/2010/main" w="9525">
                 <a:solidFill>
                   <a:srgbClr val="000000"/>
                 </a:solidFill>
@@ -1555,14 +1555,14 @@
           <a:noFill/>
           <a:extLst>
             <a:ext uri="{909E8E84-426E-40dd-AFC4-6F175D3DCCD1}">
-              <a14:hiddenFill xmlns:a14="http://schemas.microsoft.com/office/drawing/2010/main" xmlns="">
+              <a14:hiddenFill xmlns="" xmlns:a14="http://schemas.microsoft.com/office/drawing/2010/main">
                 <a:solidFill>
                   <a:srgbClr val="FFFFFF"/>
                 </a:solidFill>
               </a14:hiddenFill>
             </a:ext>
             <a:ext uri="{91240B29-F687-4f45-9708-019B960494DF}">
-              <a14:hiddenLine xmlns:a14="http://schemas.microsoft.com/office/drawing/2010/main" xmlns="" w="9525">
+              <a14:hiddenLine xmlns="" xmlns:a14="http://schemas.microsoft.com/office/drawing/2010/main" w="9525">
                 <a:solidFill>
                   <a:srgbClr val="000000"/>
                 </a:solidFill>
@@ -1710,14 +1710,14 @@
           <a:noFill/>
           <a:extLst>
             <a:ext uri="{909E8E84-426E-40dd-AFC4-6F175D3DCCD1}">
-              <a14:hiddenFill xmlns:a14="http://schemas.microsoft.com/office/drawing/2010/main" xmlns="">
+              <a14:hiddenFill xmlns="" xmlns:a14="http://schemas.microsoft.com/office/drawing/2010/main">
                 <a:solidFill>
                   <a:srgbClr val="FFFFFF"/>
                 </a:solidFill>
               </a14:hiddenFill>
             </a:ext>
             <a:ext uri="{91240B29-F687-4f45-9708-019B960494DF}">
-              <a14:hiddenLine xmlns:a14="http://schemas.microsoft.com/office/drawing/2010/main" xmlns="" w="9525">
+              <a14:hiddenLine xmlns="" xmlns:a14="http://schemas.microsoft.com/office/drawing/2010/main" w="9525">
                 <a:solidFill>
                   <a:srgbClr val="000000"/>
                 </a:solidFill>
@@ -1889,7 +1889,7 @@
         <p:spPr>
           <a:extLst>
             <a:ext uri="{FAA26D3D-D897-4be2-8F04-BA451C77F1D7}">
-              <ma14:placeholderFlag xmlns:ma14="http://schemas.microsoft.com/office/mac/drawingml/2011/main" xmlns="" val="1"/>
+              <ma14:placeholderFlag xmlns="" xmlns:ma14="http://schemas.microsoft.com/office/mac/drawingml/2011/main" val="1"/>
             </a:ext>
           </a:extLst>
         </p:spPr>
@@ -1951,14 +1951,14 @@
           <a:noFill/>
           <a:extLst>
             <a:ext uri="{909E8E84-426E-40dd-AFC4-6F175D3DCCD1}">
-              <a14:hiddenFill xmlns:a14="http://schemas.microsoft.com/office/drawing/2010/main" xmlns="">
+              <a14:hiddenFill xmlns="" xmlns:a14="http://schemas.microsoft.com/office/drawing/2010/main">
                 <a:solidFill>
                   <a:srgbClr val="FFFFFF"/>
                 </a:solidFill>
               </a14:hiddenFill>
             </a:ext>
             <a:ext uri="{91240B29-F687-4f45-9708-019B960494DF}">
-              <a14:hiddenLine xmlns:a14="http://schemas.microsoft.com/office/drawing/2010/main" xmlns="" w="9525">
+              <a14:hiddenLine xmlns="" xmlns:a14="http://schemas.microsoft.com/office/drawing/2010/main" w="9525">
                 <a:solidFill>
                   <a:srgbClr val="000000"/>
                 </a:solidFill>
@@ -2106,14 +2106,14 @@
           <a:noFill/>
           <a:extLst>
             <a:ext uri="{909E8E84-426E-40dd-AFC4-6F175D3DCCD1}">
-              <a14:hiddenFill xmlns:a14="http://schemas.microsoft.com/office/drawing/2010/main" xmlns="">
+              <a14:hiddenFill xmlns="" xmlns:a14="http://schemas.microsoft.com/office/drawing/2010/main">
                 <a:solidFill>
                   <a:srgbClr val="FFFFFF"/>
                 </a:solidFill>
               </a14:hiddenFill>
             </a:ext>
             <a:ext uri="{91240B29-F687-4f45-9708-019B960494DF}">
-              <a14:hiddenLine xmlns:a14="http://schemas.microsoft.com/office/drawing/2010/main" xmlns="" w="9525">
+              <a14:hiddenLine xmlns="" xmlns:a14="http://schemas.microsoft.com/office/drawing/2010/main" w="9525">
                 <a:solidFill>
                   <a:srgbClr val="000000"/>
                 </a:solidFill>
@@ -2261,14 +2261,14 @@
           <a:noFill/>
           <a:extLst>
             <a:ext uri="{909E8E84-426E-40dd-AFC4-6F175D3DCCD1}">
-              <a14:hiddenFill xmlns:a14="http://schemas.microsoft.com/office/drawing/2010/main" xmlns="">
+              <a14:hiddenFill xmlns="" xmlns:a14="http://schemas.microsoft.com/office/drawing/2010/main">
                 <a:solidFill>
                   <a:srgbClr val="FFFFFF"/>
                 </a:solidFill>
               </a14:hiddenFill>
             </a:ext>
             <a:ext uri="{91240B29-F687-4f45-9708-019B960494DF}">
-              <a14:hiddenLine xmlns:a14="http://schemas.microsoft.com/office/drawing/2010/main" xmlns="" w="9525">
+              <a14:hiddenLine xmlns="" xmlns:a14="http://schemas.microsoft.com/office/drawing/2010/main" w="9525">
                 <a:solidFill>
                   <a:srgbClr val="000000"/>
                 </a:solidFill>
@@ -2440,7 +2440,7 @@
         <p:spPr>
           <a:extLst>
             <a:ext uri="{FAA26D3D-D897-4be2-8F04-BA451C77F1D7}">
-              <ma14:placeholderFlag xmlns:ma14="http://schemas.microsoft.com/office/mac/drawingml/2011/main" xmlns="" val="1"/>
+              <ma14:placeholderFlag xmlns="" xmlns:ma14="http://schemas.microsoft.com/office/mac/drawingml/2011/main" val="1"/>
             </a:ext>
           </a:extLst>
         </p:spPr>
@@ -2502,14 +2502,14 @@
           <a:noFill/>
           <a:extLst>
             <a:ext uri="{909E8E84-426E-40dd-AFC4-6F175D3DCCD1}">
-              <a14:hiddenFill xmlns:a14="http://schemas.microsoft.com/office/drawing/2010/main" xmlns="">
+              <a14:hiddenFill xmlns="" xmlns:a14="http://schemas.microsoft.com/office/drawing/2010/main">
                 <a:solidFill>
                   <a:srgbClr val="FFFFFF"/>
                 </a:solidFill>
               </a14:hiddenFill>
             </a:ext>
             <a:ext uri="{91240B29-F687-4f45-9708-019B960494DF}">
-              <a14:hiddenLine xmlns:a14="http://schemas.microsoft.com/office/drawing/2010/main" xmlns="" w="9525">
+              <a14:hiddenLine xmlns="" xmlns:a14="http://schemas.microsoft.com/office/drawing/2010/main" w="9525">
                 <a:solidFill>
                   <a:srgbClr val="000000"/>
                 </a:solidFill>
@@ -2657,14 +2657,14 @@
           <a:noFill/>
           <a:extLst>
             <a:ext uri="{909E8E84-426E-40dd-AFC4-6F175D3DCCD1}">
-              <a14:hiddenFill xmlns:a14="http://schemas.microsoft.com/office/drawing/2010/main" xmlns="">
+              <a14:hiddenFill xmlns="" xmlns:a14="http://schemas.microsoft.com/office/drawing/2010/main">
                 <a:solidFill>
                   <a:srgbClr val="FFFFFF"/>
                 </a:solidFill>
               </a14:hiddenFill>
             </a:ext>
             <a:ext uri="{91240B29-F687-4f45-9708-019B960494DF}">
-              <a14:hiddenLine xmlns:a14="http://schemas.microsoft.com/office/drawing/2010/main" xmlns="" w="9525">
+              <a14:hiddenLine xmlns="" xmlns:a14="http://schemas.microsoft.com/office/drawing/2010/main" w="9525">
                 <a:solidFill>
                   <a:srgbClr val="000000"/>
                 </a:solidFill>
@@ -2812,14 +2812,14 @@
           <a:noFill/>
           <a:extLst>
             <a:ext uri="{909E8E84-426E-40dd-AFC4-6F175D3DCCD1}">
-              <a14:hiddenFill xmlns:a14="http://schemas.microsoft.com/office/drawing/2010/main" xmlns="">
+              <a14:hiddenFill xmlns="" xmlns:a14="http://schemas.microsoft.com/office/drawing/2010/main">
                 <a:solidFill>
                   <a:srgbClr val="FFFFFF"/>
                 </a:solidFill>
               </a14:hiddenFill>
             </a:ext>
             <a:ext uri="{91240B29-F687-4f45-9708-019B960494DF}">
-              <a14:hiddenLine xmlns:a14="http://schemas.microsoft.com/office/drawing/2010/main" xmlns="" w="9525">
+              <a14:hiddenLine xmlns="" xmlns:a14="http://schemas.microsoft.com/office/drawing/2010/main" w="9525">
                 <a:solidFill>
                   <a:srgbClr val="000000"/>
                 </a:solidFill>
@@ -2991,7 +2991,7 @@
         <p:spPr>
           <a:extLst>
             <a:ext uri="{FAA26D3D-D897-4be2-8F04-BA451C77F1D7}">
-              <ma14:placeholderFlag xmlns:ma14="http://schemas.microsoft.com/office/mac/drawingml/2011/main" xmlns="" val="1"/>
+              <ma14:placeholderFlag xmlns="" xmlns:ma14="http://schemas.microsoft.com/office/mac/drawingml/2011/main" val="1"/>
             </a:ext>
           </a:extLst>
         </p:spPr>
@@ -3053,14 +3053,14 @@
           <a:noFill/>
           <a:extLst>
             <a:ext uri="{909E8E84-426E-40dd-AFC4-6F175D3DCCD1}">
-              <a14:hiddenFill xmlns:a14="http://schemas.microsoft.com/office/drawing/2010/main" xmlns="">
+              <a14:hiddenFill xmlns="" xmlns:a14="http://schemas.microsoft.com/office/drawing/2010/main">
                 <a:solidFill>
                   <a:srgbClr val="FFFFFF"/>
                 </a:solidFill>
               </a14:hiddenFill>
             </a:ext>
             <a:ext uri="{91240B29-F687-4f45-9708-019B960494DF}">
-              <a14:hiddenLine xmlns:a14="http://schemas.microsoft.com/office/drawing/2010/main" xmlns="" w="9525">
+              <a14:hiddenLine xmlns="" xmlns:a14="http://schemas.microsoft.com/office/drawing/2010/main" w="9525">
                 <a:solidFill>
                   <a:srgbClr val="000000"/>
                 </a:solidFill>
@@ -3208,14 +3208,14 @@
           <a:noFill/>
           <a:extLst>
             <a:ext uri="{909E8E84-426E-40dd-AFC4-6F175D3DCCD1}">
-              <a14:hiddenFill xmlns:a14="http://schemas.microsoft.com/office/drawing/2010/main" xmlns="">
+              <a14:hiddenFill xmlns="" xmlns:a14="http://schemas.microsoft.com/office/drawing/2010/main">
                 <a:solidFill>
                   <a:srgbClr val="FFFFFF"/>
                 </a:solidFill>
               </a14:hiddenFill>
             </a:ext>
             <a:ext uri="{91240B29-F687-4f45-9708-019B960494DF}">
-              <a14:hiddenLine xmlns:a14="http://schemas.microsoft.com/office/drawing/2010/main" xmlns="" w="9525">
+              <a14:hiddenLine xmlns="" xmlns:a14="http://schemas.microsoft.com/office/drawing/2010/main" w="9525">
                 <a:solidFill>
                   <a:srgbClr val="000000"/>
                 </a:solidFill>
@@ -3363,14 +3363,14 @@
           <a:noFill/>
           <a:extLst>
             <a:ext uri="{909E8E84-426E-40dd-AFC4-6F175D3DCCD1}">
-              <a14:hiddenFill xmlns:a14="http://schemas.microsoft.com/office/drawing/2010/main" xmlns="">
+              <a14:hiddenFill xmlns="" xmlns:a14="http://schemas.microsoft.com/office/drawing/2010/main">
                 <a:solidFill>
                   <a:srgbClr val="FFFFFF"/>
                 </a:solidFill>
               </a14:hiddenFill>
             </a:ext>
             <a:ext uri="{91240B29-F687-4f45-9708-019B960494DF}">
-              <a14:hiddenLine xmlns:a14="http://schemas.microsoft.com/office/drawing/2010/main" xmlns="" w="9525">
+              <a14:hiddenLine xmlns="" xmlns:a14="http://schemas.microsoft.com/office/drawing/2010/main" w="9525">
                 <a:solidFill>
                   <a:srgbClr val="000000"/>
                 </a:solidFill>
@@ -3542,7 +3542,7 @@
         <p:spPr>
           <a:extLst>
             <a:ext uri="{FAA26D3D-D897-4be2-8F04-BA451C77F1D7}">
-              <ma14:placeholderFlag xmlns:ma14="http://schemas.microsoft.com/office/mac/drawingml/2011/main" xmlns="" val="1"/>
+              <ma14:placeholderFlag xmlns="" xmlns:ma14="http://schemas.microsoft.com/office/mac/drawingml/2011/main" val="1"/>
             </a:ext>
           </a:extLst>
         </p:spPr>
@@ -3604,14 +3604,14 @@
           <a:noFill/>
           <a:extLst>
             <a:ext uri="{909E8E84-426E-40dd-AFC4-6F175D3DCCD1}">
-              <a14:hiddenFill xmlns:a14="http://schemas.microsoft.com/office/drawing/2010/main" xmlns="">
+              <a14:hiddenFill xmlns="" xmlns:a14="http://schemas.microsoft.com/office/drawing/2010/main">
                 <a:solidFill>
                   <a:srgbClr val="FFFFFF"/>
                 </a:solidFill>
               </a14:hiddenFill>
             </a:ext>
             <a:ext uri="{91240B29-F687-4f45-9708-019B960494DF}">
-              <a14:hiddenLine xmlns:a14="http://schemas.microsoft.com/office/drawing/2010/main" xmlns="" w="9525">
+              <a14:hiddenLine xmlns="" xmlns:a14="http://schemas.microsoft.com/office/drawing/2010/main" w="9525">
                 <a:solidFill>
                   <a:srgbClr val="000000"/>
                 </a:solidFill>
@@ -3759,14 +3759,14 @@
           <a:noFill/>
           <a:extLst>
             <a:ext uri="{909E8E84-426E-40dd-AFC4-6F175D3DCCD1}">
-              <a14:hiddenFill xmlns:a14="http://schemas.microsoft.com/office/drawing/2010/main" xmlns="">
+              <a14:hiddenFill xmlns="" xmlns:a14="http://schemas.microsoft.com/office/drawing/2010/main">
                 <a:solidFill>
                   <a:srgbClr val="FFFFFF"/>
                 </a:solidFill>
               </a14:hiddenFill>
             </a:ext>
             <a:ext uri="{91240B29-F687-4f45-9708-019B960494DF}">
-              <a14:hiddenLine xmlns:a14="http://schemas.microsoft.com/office/drawing/2010/main" xmlns="" w="9525">
+              <a14:hiddenLine xmlns="" xmlns:a14="http://schemas.microsoft.com/office/drawing/2010/main" w="9525">
                 <a:solidFill>
                   <a:srgbClr val="000000"/>
                 </a:solidFill>
@@ -3914,14 +3914,14 @@
           <a:noFill/>
           <a:extLst>
             <a:ext uri="{909E8E84-426E-40dd-AFC4-6F175D3DCCD1}">
-              <a14:hiddenFill xmlns:a14="http://schemas.microsoft.com/office/drawing/2010/main" xmlns="">
+              <a14:hiddenFill xmlns="" xmlns:a14="http://schemas.microsoft.com/office/drawing/2010/main">
                 <a:solidFill>
                   <a:srgbClr val="FFFFFF"/>
                 </a:solidFill>
               </a14:hiddenFill>
             </a:ext>
             <a:ext uri="{91240B29-F687-4f45-9708-019B960494DF}">
-              <a14:hiddenLine xmlns:a14="http://schemas.microsoft.com/office/drawing/2010/main" xmlns="" w="9525">
+              <a14:hiddenLine xmlns="" xmlns:a14="http://schemas.microsoft.com/office/drawing/2010/main" w="9525">
                 <a:solidFill>
                   <a:srgbClr val="000000"/>
                 </a:solidFill>
@@ -4093,7 +4093,7 @@
         <p:spPr>
           <a:extLst>
             <a:ext uri="{FAA26D3D-D897-4be2-8F04-BA451C77F1D7}">
-              <ma14:placeholderFlag xmlns:ma14="http://schemas.microsoft.com/office/mac/drawingml/2011/main" xmlns="" val="1"/>
+              <ma14:placeholderFlag xmlns="" xmlns:ma14="http://schemas.microsoft.com/office/mac/drawingml/2011/main" val="1"/>
             </a:ext>
           </a:extLst>
         </p:spPr>
@@ -4155,14 +4155,14 @@
           <a:noFill/>
           <a:extLst>
             <a:ext uri="{909E8E84-426E-40dd-AFC4-6F175D3DCCD1}">
-              <a14:hiddenFill xmlns:a14="http://schemas.microsoft.com/office/drawing/2010/main" xmlns="">
+              <a14:hiddenFill xmlns="" xmlns:a14="http://schemas.microsoft.com/office/drawing/2010/main">
                 <a:solidFill>
                   <a:srgbClr val="FFFFFF"/>
                 </a:solidFill>
               </a14:hiddenFill>
             </a:ext>
             <a:ext uri="{91240B29-F687-4f45-9708-019B960494DF}">
-              <a14:hiddenLine xmlns:a14="http://schemas.microsoft.com/office/drawing/2010/main" xmlns="" w="9525">
+              <a14:hiddenLine xmlns="" xmlns:a14="http://schemas.microsoft.com/office/drawing/2010/main" w="9525">
                 <a:solidFill>
                   <a:srgbClr val="000000"/>
                 </a:solidFill>
@@ -4310,14 +4310,14 @@
           <a:noFill/>
           <a:extLst>
             <a:ext uri="{909E8E84-426E-40dd-AFC4-6F175D3DCCD1}">
-              <a14:hiddenFill xmlns:a14="http://schemas.microsoft.com/office/drawing/2010/main" xmlns="">
+              <a14:hiddenFill xmlns="" xmlns:a14="http://schemas.microsoft.com/office/drawing/2010/main">
                 <a:solidFill>
                   <a:srgbClr val="FFFFFF"/>
                 </a:solidFill>
               </a14:hiddenFill>
             </a:ext>
             <a:ext uri="{91240B29-F687-4f45-9708-019B960494DF}">
-              <a14:hiddenLine xmlns:a14="http://schemas.microsoft.com/office/drawing/2010/main" xmlns="" w="9525">
+              <a14:hiddenLine xmlns="" xmlns:a14="http://schemas.microsoft.com/office/drawing/2010/main" w="9525">
                 <a:solidFill>
                   <a:srgbClr val="000000"/>
                 </a:solidFill>
@@ -4465,14 +4465,14 @@
           <a:noFill/>
           <a:extLst>
             <a:ext uri="{909E8E84-426E-40dd-AFC4-6F175D3DCCD1}">
-              <a14:hiddenFill xmlns:a14="http://schemas.microsoft.com/office/drawing/2010/main" xmlns="">
+              <a14:hiddenFill xmlns="" xmlns:a14="http://schemas.microsoft.com/office/drawing/2010/main">
                 <a:solidFill>
                   <a:srgbClr val="FFFFFF"/>
                 </a:solidFill>
               </a14:hiddenFill>
             </a:ext>
             <a:ext uri="{91240B29-F687-4f45-9708-019B960494DF}">
-              <a14:hiddenLine xmlns:a14="http://schemas.microsoft.com/office/drawing/2010/main" xmlns="" w="9525">
+              <a14:hiddenLine xmlns="" xmlns:a14="http://schemas.microsoft.com/office/drawing/2010/main" w="9525">
                 <a:solidFill>
                   <a:srgbClr val="000000"/>
                 </a:solidFill>
@@ -4644,7 +4644,7 @@
         <p:spPr>
           <a:extLst>
             <a:ext uri="{FAA26D3D-D897-4be2-8F04-BA451C77F1D7}">
-              <ma14:placeholderFlag xmlns:ma14="http://schemas.microsoft.com/office/mac/drawingml/2011/main" xmlns="" val="1"/>
+              <ma14:placeholderFlag xmlns="" xmlns:ma14="http://schemas.microsoft.com/office/mac/drawingml/2011/main" val="1"/>
             </a:ext>
           </a:extLst>
         </p:spPr>
@@ -4706,14 +4706,14 @@
           <a:noFill/>
           <a:extLst>
             <a:ext uri="{909E8E84-426E-40dd-AFC4-6F175D3DCCD1}">
-              <a14:hiddenFill xmlns:a14="http://schemas.microsoft.com/office/drawing/2010/main" xmlns="">
+              <a14:hiddenFill xmlns="" xmlns:a14="http://schemas.microsoft.com/office/drawing/2010/main">
                 <a:solidFill>
                   <a:srgbClr val="FFFFFF"/>
                 </a:solidFill>
               </a14:hiddenFill>
             </a:ext>
             <a:ext uri="{91240B29-F687-4f45-9708-019B960494DF}">
-              <a14:hiddenLine xmlns:a14="http://schemas.microsoft.com/office/drawing/2010/main" xmlns="" w="9525">
+              <a14:hiddenLine xmlns="" xmlns:a14="http://schemas.microsoft.com/office/drawing/2010/main" w="9525">
                 <a:solidFill>
                   <a:srgbClr val="000000"/>
                 </a:solidFill>
@@ -4861,14 +4861,14 @@
           <a:noFill/>
           <a:extLst>
             <a:ext uri="{909E8E84-426E-40dd-AFC4-6F175D3DCCD1}">
-              <a14:hiddenFill xmlns:a14="http://schemas.microsoft.com/office/drawing/2010/main" xmlns="">
+              <a14:hiddenFill xmlns="" xmlns:a14="http://schemas.microsoft.com/office/drawing/2010/main">
                 <a:solidFill>
                   <a:srgbClr val="FFFFFF"/>
                 </a:solidFill>
               </a14:hiddenFill>
             </a:ext>
             <a:ext uri="{91240B29-F687-4f45-9708-019B960494DF}">
-              <a14:hiddenLine xmlns:a14="http://schemas.microsoft.com/office/drawing/2010/main" xmlns="" w="9525">
+              <a14:hiddenLine xmlns="" xmlns:a14="http://schemas.microsoft.com/office/drawing/2010/main" w="9525">
                 <a:solidFill>
                   <a:srgbClr val="000000"/>
                 </a:solidFill>
@@ -5016,14 +5016,14 @@
           <a:noFill/>
           <a:extLst>
             <a:ext uri="{909E8E84-426E-40dd-AFC4-6F175D3DCCD1}">
-              <a14:hiddenFill xmlns:a14="http://schemas.microsoft.com/office/drawing/2010/main" xmlns="">
+              <a14:hiddenFill xmlns="" xmlns:a14="http://schemas.microsoft.com/office/drawing/2010/main">
                 <a:solidFill>
                   <a:srgbClr val="FFFFFF"/>
                 </a:solidFill>
               </a14:hiddenFill>
             </a:ext>
             <a:ext uri="{91240B29-F687-4f45-9708-019B960494DF}">
-              <a14:hiddenLine xmlns:a14="http://schemas.microsoft.com/office/drawing/2010/main" xmlns="" w="9525">
+              <a14:hiddenLine xmlns="" xmlns:a14="http://schemas.microsoft.com/office/drawing/2010/main" w="9525">
                 <a:solidFill>
                   <a:srgbClr val="000000"/>
                 </a:solidFill>
@@ -5195,7 +5195,7 @@
         <p:spPr>
           <a:extLst>
             <a:ext uri="{FAA26D3D-D897-4be2-8F04-BA451C77F1D7}">
-              <ma14:placeholderFlag xmlns:ma14="http://schemas.microsoft.com/office/mac/drawingml/2011/main" xmlns="" val="1"/>
+              <ma14:placeholderFlag xmlns="" xmlns:ma14="http://schemas.microsoft.com/office/mac/drawingml/2011/main" val="1"/>
             </a:ext>
           </a:extLst>
         </p:spPr>
@@ -5257,14 +5257,14 @@
           <a:noFill/>
           <a:extLst>
             <a:ext uri="{909E8E84-426E-40dd-AFC4-6F175D3DCCD1}">
-              <a14:hiddenFill xmlns:a14="http://schemas.microsoft.com/office/drawing/2010/main" xmlns="">
+              <a14:hiddenFill xmlns="" xmlns:a14="http://schemas.microsoft.com/office/drawing/2010/main">
                 <a:solidFill>
                   <a:srgbClr val="FFFFFF"/>
                 </a:solidFill>
               </a14:hiddenFill>
             </a:ext>
             <a:ext uri="{91240B29-F687-4f45-9708-019B960494DF}">
-              <a14:hiddenLine xmlns:a14="http://schemas.microsoft.com/office/drawing/2010/main" xmlns="" w="9525">
+              <a14:hiddenLine xmlns="" xmlns:a14="http://schemas.microsoft.com/office/drawing/2010/main" w="9525">
                 <a:solidFill>
                   <a:srgbClr val="000000"/>
                 </a:solidFill>
@@ -5412,14 +5412,14 @@
           <a:noFill/>
           <a:extLst>
             <a:ext uri="{909E8E84-426E-40dd-AFC4-6F175D3DCCD1}">
-              <a14:hiddenFill xmlns:a14="http://schemas.microsoft.com/office/drawing/2010/main" xmlns="">
+              <a14:hiddenFill xmlns="" xmlns:a14="http://schemas.microsoft.com/office/drawing/2010/main">
                 <a:solidFill>
                   <a:srgbClr val="FFFFFF"/>
                 </a:solidFill>
               </a14:hiddenFill>
             </a:ext>
             <a:ext uri="{91240B29-F687-4f45-9708-019B960494DF}">
-              <a14:hiddenLine xmlns:a14="http://schemas.microsoft.com/office/drawing/2010/main" xmlns="" w="9525">
+              <a14:hiddenLine xmlns="" xmlns:a14="http://schemas.microsoft.com/office/drawing/2010/main" w="9525">
                 <a:solidFill>
                   <a:srgbClr val="000000"/>
                 </a:solidFill>
@@ -5567,14 +5567,14 @@
           <a:noFill/>
           <a:extLst>
             <a:ext uri="{909E8E84-426E-40dd-AFC4-6F175D3DCCD1}">
-              <a14:hiddenFill xmlns:a14="http://schemas.microsoft.com/office/drawing/2010/main" xmlns="">
+              <a14:hiddenFill xmlns="" xmlns:a14="http://schemas.microsoft.com/office/drawing/2010/main">
                 <a:solidFill>
                   <a:srgbClr val="FFFFFF"/>
                 </a:solidFill>
               </a14:hiddenFill>
             </a:ext>
             <a:ext uri="{91240B29-F687-4f45-9708-019B960494DF}">
-              <a14:hiddenLine xmlns:a14="http://schemas.microsoft.com/office/drawing/2010/main" xmlns="" w="9525">
+              <a14:hiddenLine xmlns="" xmlns:a14="http://schemas.microsoft.com/office/drawing/2010/main" w="9525">
                 <a:solidFill>
                   <a:srgbClr val="000000"/>
                 </a:solidFill>
@@ -5746,7 +5746,7 @@
         <p:spPr>
           <a:extLst>
             <a:ext uri="{FAA26D3D-D897-4be2-8F04-BA451C77F1D7}">
-              <ma14:placeholderFlag xmlns:ma14="http://schemas.microsoft.com/office/mac/drawingml/2011/main" xmlns="" val="1"/>
+              <ma14:placeholderFlag xmlns="" xmlns:ma14="http://schemas.microsoft.com/office/mac/drawingml/2011/main" val="1"/>
             </a:ext>
           </a:extLst>
         </p:spPr>
@@ -5808,14 +5808,14 @@
           <a:noFill/>
           <a:extLst>
             <a:ext uri="{909E8E84-426E-40dd-AFC4-6F175D3DCCD1}">
-              <a14:hiddenFill xmlns:a14="http://schemas.microsoft.com/office/drawing/2010/main" xmlns="">
+              <a14:hiddenFill xmlns="" xmlns:a14="http://schemas.microsoft.com/office/drawing/2010/main">
                 <a:solidFill>
                   <a:srgbClr val="FFFFFF"/>
                 </a:solidFill>
               </a14:hiddenFill>
             </a:ext>
             <a:ext uri="{91240B29-F687-4f45-9708-019B960494DF}">
-              <a14:hiddenLine xmlns:a14="http://schemas.microsoft.com/office/drawing/2010/main" xmlns="" w="9525">
+              <a14:hiddenLine xmlns="" xmlns:a14="http://schemas.microsoft.com/office/drawing/2010/main" w="9525">
                 <a:solidFill>
                   <a:srgbClr val="000000"/>
                 </a:solidFill>
@@ -5963,14 +5963,14 @@
           <a:noFill/>
           <a:extLst>
             <a:ext uri="{909E8E84-426E-40dd-AFC4-6F175D3DCCD1}">
-              <a14:hiddenFill xmlns:a14="http://schemas.microsoft.com/office/drawing/2010/main" xmlns="">
+              <a14:hiddenFill xmlns="" xmlns:a14="http://schemas.microsoft.com/office/drawing/2010/main">
                 <a:solidFill>
                   <a:srgbClr val="FFFFFF"/>
                 </a:solidFill>
               </a14:hiddenFill>
             </a:ext>
             <a:ext uri="{91240B29-F687-4f45-9708-019B960494DF}">
-              <a14:hiddenLine xmlns:a14="http://schemas.microsoft.com/office/drawing/2010/main" xmlns="" w="9525">
+              <a14:hiddenLine xmlns="" xmlns:a14="http://schemas.microsoft.com/office/drawing/2010/main" w="9525">
                 <a:solidFill>
                   <a:srgbClr val="000000"/>
                 </a:solidFill>
@@ -6118,14 +6118,14 @@
           <a:noFill/>
           <a:extLst>
             <a:ext uri="{909E8E84-426E-40dd-AFC4-6F175D3DCCD1}">
-              <a14:hiddenFill xmlns:a14="http://schemas.microsoft.com/office/drawing/2010/main" xmlns="">
+              <a14:hiddenFill xmlns="" xmlns:a14="http://schemas.microsoft.com/office/drawing/2010/main">
                 <a:solidFill>
                   <a:srgbClr val="FFFFFF"/>
                 </a:solidFill>
               </a14:hiddenFill>
             </a:ext>
             <a:ext uri="{91240B29-F687-4f45-9708-019B960494DF}">
-              <a14:hiddenLine xmlns:a14="http://schemas.microsoft.com/office/drawing/2010/main" xmlns="" w="9525">
+              <a14:hiddenLine xmlns="" xmlns:a14="http://schemas.microsoft.com/office/drawing/2010/main" w="9525">
                 <a:solidFill>
                   <a:srgbClr val="000000"/>
                 </a:solidFill>
@@ -6297,7 +6297,7 @@
         <p:spPr>
           <a:extLst>
             <a:ext uri="{FAA26D3D-D897-4be2-8F04-BA451C77F1D7}">
-              <ma14:placeholderFlag xmlns:ma14="http://schemas.microsoft.com/office/mac/drawingml/2011/main" xmlns="" val="1"/>
+              <ma14:placeholderFlag xmlns="" xmlns:ma14="http://schemas.microsoft.com/office/mac/drawingml/2011/main" val="1"/>
             </a:ext>
           </a:extLst>
         </p:spPr>
@@ -6359,14 +6359,14 @@
           <a:noFill/>
           <a:extLst>
             <a:ext uri="{909E8E84-426E-40dd-AFC4-6F175D3DCCD1}">
-              <a14:hiddenFill xmlns:a14="http://schemas.microsoft.com/office/drawing/2010/main" xmlns="">
+              <a14:hiddenFill xmlns="" xmlns:a14="http://schemas.microsoft.com/office/drawing/2010/main">
                 <a:solidFill>
                   <a:srgbClr val="FFFFFF"/>
                 </a:solidFill>
               </a14:hiddenFill>
             </a:ext>
             <a:ext uri="{91240B29-F687-4f45-9708-019B960494DF}">
-              <a14:hiddenLine xmlns:a14="http://schemas.microsoft.com/office/drawing/2010/main" xmlns="" w="9525">
+              <a14:hiddenLine xmlns="" xmlns:a14="http://schemas.microsoft.com/office/drawing/2010/main" w="9525">
                 <a:solidFill>
                   <a:srgbClr val="000000"/>
                 </a:solidFill>
@@ -6514,14 +6514,14 @@
           <a:noFill/>
           <a:extLst>
             <a:ext uri="{909E8E84-426E-40dd-AFC4-6F175D3DCCD1}">
-              <a14:hiddenFill xmlns:a14="http://schemas.microsoft.com/office/drawing/2010/main" xmlns="">
+              <a14:hiddenFill xmlns="" xmlns:a14="http://schemas.microsoft.com/office/drawing/2010/main">
                 <a:solidFill>
                   <a:srgbClr val="FFFFFF"/>
                 </a:solidFill>
               </a14:hiddenFill>
             </a:ext>
             <a:ext uri="{91240B29-F687-4f45-9708-019B960494DF}">
-              <a14:hiddenLine xmlns:a14="http://schemas.microsoft.com/office/drawing/2010/main" xmlns="" w="9525">
+              <a14:hiddenLine xmlns="" xmlns:a14="http://schemas.microsoft.com/office/drawing/2010/main" w="9525">
                 <a:solidFill>
                   <a:srgbClr val="000000"/>
                 </a:solidFill>
@@ -6669,14 +6669,14 @@
           <a:noFill/>
           <a:extLst>
             <a:ext uri="{909E8E84-426E-40dd-AFC4-6F175D3DCCD1}">
-              <a14:hiddenFill xmlns:a14="http://schemas.microsoft.com/office/drawing/2010/main" xmlns="">
+              <a14:hiddenFill xmlns="" xmlns:a14="http://schemas.microsoft.com/office/drawing/2010/main">
                 <a:solidFill>
                   <a:srgbClr val="FFFFFF"/>
                 </a:solidFill>
               </a14:hiddenFill>
             </a:ext>
             <a:ext uri="{91240B29-F687-4f45-9708-019B960494DF}">
-              <a14:hiddenLine xmlns:a14="http://schemas.microsoft.com/office/drawing/2010/main" xmlns="" w="9525">
+              <a14:hiddenLine xmlns="" xmlns:a14="http://schemas.microsoft.com/office/drawing/2010/main" w="9525">
                 <a:solidFill>
                   <a:srgbClr val="000000"/>
                 </a:solidFill>
@@ -6848,7 +6848,7 @@
         <p:spPr>
           <a:extLst>
             <a:ext uri="{FAA26D3D-D897-4be2-8F04-BA451C77F1D7}">
-              <ma14:placeholderFlag xmlns:ma14="http://schemas.microsoft.com/office/mac/drawingml/2011/main" xmlns="" val="1"/>
+              <ma14:placeholderFlag xmlns="" xmlns:ma14="http://schemas.microsoft.com/office/mac/drawingml/2011/main" val="1"/>
             </a:ext>
           </a:extLst>
         </p:spPr>
@@ -7060,7 +7060,7 @@
           <a:p>
             <a:fld id="{C764DE79-268F-4C1A-8933-263129D2AF90}" type="datetimeFigureOut">
               <a:rPr lang="en-US" smtClean="0"/>
-              <a:t>9/20/25</a:t>
+              <a:t>10/16/25</a:t>
             </a:fld>
             <a:endParaRPr lang="en-US" dirty="0"/>
           </a:p>
@@ -7231,7 +7231,7 @@
           <a:p>
             <a:fld id="{C764DE79-268F-4C1A-8933-263129D2AF90}" type="datetimeFigureOut">
               <a:rPr lang="en-US" smtClean="0"/>
-              <a:t>9/20/25</a:t>
+              <a:t>10/16/25</a:t>
             </a:fld>
             <a:endParaRPr lang="en-US" dirty="0"/>
           </a:p>
@@ -7412,7 +7412,7 @@
           <a:p>
             <a:fld id="{C764DE79-268F-4C1A-8933-263129D2AF90}" type="datetimeFigureOut">
               <a:rPr lang="en-US" smtClean="0"/>
-              <a:t>9/20/25</a:t>
+              <a:t>10/16/25</a:t>
             </a:fld>
             <a:endParaRPr lang="en-US" dirty="0"/>
           </a:p>
@@ -8139,7 +8139,7 @@
           <a:p>
             <a:fld id="{C764DE79-268F-4C1A-8933-263129D2AF90}" type="datetimeFigureOut">
               <a:rPr lang="en-US" smtClean="0"/>
-              <a:t>9/20/25</a:t>
+              <a:t>10/16/25</a:t>
             </a:fld>
             <a:endParaRPr lang="en-US" dirty="0"/>
           </a:p>
@@ -8511,7 +8511,7 @@
           <a:p>
             <a:fld id="{C764DE79-268F-4C1A-8933-263129D2AF90}" type="datetimeFigureOut">
               <a:rPr lang="en-US" smtClean="0"/>
-              <a:t>9/20/25</a:t>
+              <a:t>10/16/25</a:t>
             </a:fld>
             <a:endParaRPr lang="en-US" dirty="0"/>
           </a:p>
@@ -8811,7 +8811,7 @@
           <a:p>
             <a:fld id="{C764DE79-268F-4C1A-8933-263129D2AF90}" type="datetimeFigureOut">
               <a:rPr lang="en-US" smtClean="0"/>
-              <a:t>9/20/25</a:t>
+              <a:t>10/16/25</a:t>
             </a:fld>
             <a:endParaRPr lang="en-US" dirty="0"/>
           </a:p>
@@ -9358,7 +9358,7 @@
           <a:p>
             <a:fld id="{C764DE79-268F-4C1A-8933-263129D2AF90}" type="datetimeFigureOut">
               <a:rPr lang="en-US" smtClean="0"/>
-              <a:t>9/20/25</a:t>
+              <a:t>10/16/25</a:t>
             </a:fld>
             <a:endParaRPr lang="en-US" dirty="0"/>
           </a:p>
@@ -9564,7 +9564,7 @@
           <a:p>
             <a:fld id="{C764DE79-268F-4C1A-8933-263129D2AF90}" type="datetimeFigureOut">
               <a:rPr lang="en-US" smtClean="0"/>
-              <a:t>9/20/25</a:t>
+              <a:t>10/16/25</a:t>
             </a:fld>
             <a:endParaRPr lang="en-US" dirty="0"/>
           </a:p>
@@ -9776,7 +9776,7 @@
           <a:p>
             <a:fld id="{C764DE79-268F-4C1A-8933-263129D2AF90}" type="datetimeFigureOut">
               <a:rPr lang="en-US" smtClean="0"/>
-              <a:t>9/20/25</a:t>
+              <a:t>10/16/25</a:t>
             </a:fld>
             <a:endParaRPr lang="en-US" dirty="0"/>
           </a:p>
@@ -10053,7 +10053,7 @@
           <a:p>
             <a:fld id="{C764DE79-268F-4C1A-8933-263129D2AF90}" type="datetimeFigureOut">
               <a:rPr lang="en-US" smtClean="0"/>
-              <a:t>9/20/25</a:t>
+              <a:t>10/16/25</a:t>
             </a:fld>
             <a:endParaRPr lang="en-US" dirty="0"/>
           </a:p>
@@ -10311,7 +10311,7 @@
           <a:p>
             <a:fld id="{C764DE79-268F-4C1A-8933-263129D2AF90}" type="datetimeFigureOut">
               <a:rPr lang="en-US" smtClean="0"/>
-              <a:t>9/20/25</a:t>
+              <a:t>10/16/25</a:t>
             </a:fld>
             <a:endParaRPr lang="en-US" dirty="0"/>
           </a:p>
@@ -10530,7 +10530,7 @@
           <a:p>
             <a:fld id="{C764DE79-268F-4C1A-8933-263129D2AF90}" type="datetimeFigureOut">
               <a:rPr lang="en-US" smtClean="0"/>
-              <a:t>9/20/25</a:t>
+              <a:t>10/16/25</a:t>
             </a:fld>
             <a:endParaRPr lang="en-US" dirty="0"/>
           </a:p>
@@ -11000,14 +11000,14 @@
           </a:ln>
           <a:extLst>
             <a:ext uri="{909E8E84-426E-40dd-AFC4-6F175D3DCCD1}">
-              <a14:hiddenFill xmlns:a14="http://schemas.microsoft.com/office/drawing/2010/main" xmlns="">
+              <a14:hiddenFill xmlns="" xmlns:a14="http://schemas.microsoft.com/office/drawing/2010/main">
                 <a:solidFill>
                   <a:srgbClr val="FFFFFF"/>
                 </a:solidFill>
               </a14:hiddenFill>
             </a:ext>
             <a:ext uri="{91240B29-F687-4f45-9708-019B960494DF}">
-              <a14:hiddenLine xmlns:a14="http://schemas.microsoft.com/office/drawing/2010/main" xmlns="" w="9525">
+              <a14:hiddenLine xmlns="" xmlns:a14="http://schemas.microsoft.com/office/drawing/2010/main" w="9525">
                 <a:solidFill>
                   <a:srgbClr val="000000"/>
                 </a:solidFill>
@@ -11438,42 +11438,6 @@
           </a:p>
         </p:txBody>
       </p:sp>
-      <p:pic>
-        <p:nvPicPr>
-          <p:cNvPr id="4" name="Picture 3" descr="Text&#10;&#10;Description automatically generated">
-            <a:extLst>
-              <a:ext uri="{FF2B5EF4-FFF2-40B4-BE49-F238E27FC236}">
-                <a16:creationId xmlns:a16="http://schemas.microsoft.com/office/drawing/2014/main" id="{3C52B6A4-97C1-5BF3-8F44-19C73FB40166}"/>
-              </a:ext>
-            </a:extLst>
-          </p:cNvPr>
-          <p:cNvPicPr>
-            <a:picLocks noChangeAspect="1"/>
-          </p:cNvPicPr>
-          <p:nvPr/>
-        </p:nvPicPr>
-        <p:blipFill>
-          <a:blip r:embed="rId3" cstate="print">
-            <a:extLst>
-              <a:ext uri="{28A0092B-C50C-407E-A947-70E740481C1C}">
-                <a14:useLocalDpi xmlns:a14="http://schemas.microsoft.com/office/drawing/2010/main" val="0"/>
-              </a:ext>
-            </a:extLst>
-          </a:blip>
-          <a:stretch>
-            <a:fillRect/>
-          </a:stretch>
-        </p:blipFill>
-        <p:spPr>
-          <a:xfrm>
-            <a:off x="651641" y="5501441"/>
-            <a:ext cx="2286000" cy="1281546"/>
-          </a:xfrm>
-          <a:prstGeom prst="rect">
-            <a:avLst/>
-          </a:prstGeom>
-        </p:spPr>
-      </p:pic>
       <p:sp>
         <p:nvSpPr>
           <p:cNvPr id="5" name="TextBox 4">
@@ -11544,7 +11508,7 @@
           <p:nvPr/>
         </p:nvPicPr>
         <p:blipFill>
-          <a:blip r:embed="rId4">
+          <a:blip r:embed="rId3">
             <a:extLst>
               <a:ext uri="{28A0092B-C50C-407E-A947-70E740481C1C}">
                 <a14:useLocalDpi xmlns:a14="http://schemas.microsoft.com/office/drawing/2010/main" val="0"/>
@@ -11574,6 +11538,42 @@
               </a14:hiddenFill>
             </a:ext>
           </a:extLst>
+        </p:spPr>
+      </p:pic>
+      <p:pic>
+        <p:nvPicPr>
+          <p:cNvPr id="7" name="Picture 6">
+            <a:extLst>
+              <a:ext uri="{FF2B5EF4-FFF2-40B4-BE49-F238E27FC236}">
+                <a16:creationId xmlns:a16="http://schemas.microsoft.com/office/drawing/2014/main" id="{04E3E16E-FBE5-7D50-16CA-CF998764CAFE}"/>
+              </a:ext>
+            </a:extLst>
+          </p:cNvPr>
+          <p:cNvPicPr>
+            <a:picLocks noChangeAspect="1"/>
+          </p:cNvPicPr>
+          <p:nvPr/>
+        </p:nvPicPr>
+        <p:blipFill>
+          <a:blip r:embed="rId4" cstate="print">
+            <a:extLst>
+              <a:ext uri="{28A0092B-C50C-407E-A947-70E740481C1C}">
+                <a14:useLocalDpi xmlns:a14="http://schemas.microsoft.com/office/drawing/2010/main" val="0"/>
+              </a:ext>
+            </a:extLst>
+          </a:blip>
+          <a:stretch>
+            <a:fillRect/>
+          </a:stretch>
+        </p:blipFill>
+        <p:spPr>
+          <a:xfrm>
+            <a:off x="499242" y="5565517"/>
+            <a:ext cx="2057400" cy="1153391"/>
+          </a:xfrm>
+          <a:prstGeom prst="rect">
+            <a:avLst/>
+          </a:prstGeom>
         </p:spPr>
       </p:pic>
     </p:spTree>
@@ -12594,14 +12594,14 @@
           <a:noFill/>
           <a:extLst>
             <a:ext uri="{909E8E84-426E-40dd-AFC4-6F175D3DCCD1}">
-              <a14:hiddenFill xmlns:a14="http://schemas.microsoft.com/office/drawing/2010/main" xmlns="">
+              <a14:hiddenFill xmlns="" xmlns:a14="http://schemas.microsoft.com/office/drawing/2010/main">
                 <a:solidFill>
                   <a:srgbClr val="FFFFFF"/>
                 </a:solidFill>
               </a14:hiddenFill>
             </a:ext>
             <a:ext uri="{91240B29-F687-4f45-9708-019B960494DF}">
-              <a14:hiddenLine xmlns:a14="http://schemas.microsoft.com/office/drawing/2010/main" xmlns="" w="9525">
+              <a14:hiddenLine xmlns="" xmlns:a14="http://schemas.microsoft.com/office/drawing/2010/main" w="9525">
                 <a:solidFill>
                   <a:srgbClr val="000000"/>
                 </a:solidFill>
@@ -12818,7 +12818,7 @@
           </a:ln>
           <a:extLst>
             <a:ext uri="{909E8E84-426E-40dd-AFC4-6F175D3DCCD1}">
-              <a14:hiddenFill xmlns:a14="http://schemas.microsoft.com/office/drawing/2010/main" xmlns="">
+              <a14:hiddenFill xmlns="" xmlns:a14="http://schemas.microsoft.com/office/drawing/2010/main">
                 <a:solidFill>
                   <a:srgbClr val="FFFFFF"/>
                 </a:solidFill>
@@ -13195,14 +13195,14 @@
           </a:ln>
           <a:extLst>
             <a:ext uri="{909E8E84-426E-40dd-AFC4-6F175D3DCCD1}">
-              <a14:hiddenFill xmlns:a14="http://schemas.microsoft.com/office/drawing/2010/main" xmlns="">
+              <a14:hiddenFill xmlns="" xmlns:a14="http://schemas.microsoft.com/office/drawing/2010/main">
                 <a:solidFill>
                   <a:srgbClr val="FFFFFF"/>
                 </a:solidFill>
               </a14:hiddenFill>
             </a:ext>
             <a:ext uri="{91240B29-F687-4f45-9708-019B960494DF}">
-              <a14:hiddenLine xmlns:a14="http://schemas.microsoft.com/office/drawing/2010/main" xmlns="" w="9525">
+              <a14:hiddenLine xmlns="" xmlns:a14="http://schemas.microsoft.com/office/drawing/2010/main" w="9525">
                 <a:solidFill>
                   <a:srgbClr val="000000"/>
                 </a:solidFill>
@@ -13419,14 +13419,14 @@
           </a:ln>
           <a:extLst>
             <a:ext uri="{909E8E84-426E-40dd-AFC4-6F175D3DCCD1}">
-              <a14:hiddenFill xmlns:a14="http://schemas.microsoft.com/office/drawing/2010/main" xmlns="">
+              <a14:hiddenFill xmlns="" xmlns:a14="http://schemas.microsoft.com/office/drawing/2010/main">
                 <a:solidFill>
                   <a:srgbClr val="FFFFFF"/>
                 </a:solidFill>
               </a14:hiddenFill>
             </a:ext>
             <a:ext uri="{91240B29-F687-4f45-9708-019B960494DF}">
-              <a14:hiddenLine xmlns:a14="http://schemas.microsoft.com/office/drawing/2010/main" xmlns="" w="9525">
+              <a14:hiddenLine xmlns="" xmlns:a14="http://schemas.microsoft.com/office/drawing/2010/main" w="9525">
                 <a:solidFill>
                   <a:srgbClr val="000000"/>
                 </a:solidFill>
@@ -13642,14 +13642,14 @@
           </a:ln>
           <a:extLst>
             <a:ext uri="{909E8E84-426E-40dd-AFC4-6F175D3DCCD1}">
-              <a14:hiddenFill xmlns:a14="http://schemas.microsoft.com/office/drawing/2010/main" xmlns="">
+              <a14:hiddenFill xmlns="" xmlns:a14="http://schemas.microsoft.com/office/drawing/2010/main">
                 <a:solidFill>
                   <a:srgbClr val="FFFFFF"/>
                 </a:solidFill>
               </a14:hiddenFill>
             </a:ext>
             <a:ext uri="{91240B29-F687-4f45-9708-019B960494DF}">
-              <a14:hiddenLine xmlns:a14="http://schemas.microsoft.com/office/drawing/2010/main" xmlns="" w="9525">
+              <a14:hiddenLine xmlns="" xmlns:a14="http://schemas.microsoft.com/office/drawing/2010/main" w="9525">
                 <a:solidFill>
                   <a:srgbClr val="000000"/>
                 </a:solidFill>
@@ -13865,14 +13865,14 @@
           </a:ln>
           <a:extLst>
             <a:ext uri="{909E8E84-426E-40dd-AFC4-6F175D3DCCD1}">
-              <a14:hiddenFill xmlns:a14="http://schemas.microsoft.com/office/drawing/2010/main" xmlns="">
+              <a14:hiddenFill xmlns="" xmlns:a14="http://schemas.microsoft.com/office/drawing/2010/main">
                 <a:solidFill>
                   <a:srgbClr val="FFFFFF"/>
                 </a:solidFill>
               </a14:hiddenFill>
             </a:ext>
             <a:ext uri="{91240B29-F687-4f45-9708-019B960494DF}">
-              <a14:hiddenLine xmlns:a14="http://schemas.microsoft.com/office/drawing/2010/main" xmlns="" w="9525">
+              <a14:hiddenLine xmlns="" xmlns:a14="http://schemas.microsoft.com/office/drawing/2010/main" w="9525">
                 <a:solidFill>
                   <a:srgbClr val="000000"/>
                 </a:solidFill>
@@ -14093,7 +14093,7 @@
           </a:ln>
           <a:extLst>
             <a:ext uri="{909E8E84-426E-40dd-AFC4-6F175D3DCCD1}">
-              <a14:hiddenFill xmlns:a14="http://schemas.microsoft.com/office/drawing/2010/main" xmlns="">
+              <a14:hiddenFill xmlns="" xmlns:a14="http://schemas.microsoft.com/office/drawing/2010/main">
                 <a:noFill/>
               </a14:hiddenFill>
             </a:ext>
@@ -14134,7 +14134,7 @@
           </a:ln>
           <a:extLst>
             <a:ext uri="{909E8E84-426E-40dd-AFC4-6F175D3DCCD1}">
-              <a14:hiddenFill xmlns:a14="http://schemas.microsoft.com/office/drawing/2010/main" xmlns="">
+              <a14:hiddenFill xmlns="" xmlns:a14="http://schemas.microsoft.com/office/drawing/2010/main">
                 <a:noFill/>
               </a14:hiddenFill>
             </a:ext>
@@ -14175,7 +14175,7 @@
           </a:ln>
           <a:extLst>
             <a:ext uri="{909E8E84-426E-40dd-AFC4-6F175D3DCCD1}">
-              <a14:hiddenFill xmlns:a14="http://schemas.microsoft.com/office/drawing/2010/main" xmlns="">
+              <a14:hiddenFill xmlns="" xmlns:a14="http://schemas.microsoft.com/office/drawing/2010/main">
                 <a:noFill/>
               </a14:hiddenFill>
             </a:ext>
@@ -15350,14 +15350,14 @@
           </a:ln>
           <a:extLst>
             <a:ext uri="{909E8E84-426E-40dd-AFC4-6F175D3DCCD1}">
-              <a14:hiddenFill xmlns:a14="http://schemas.microsoft.com/office/drawing/2010/main" xmlns="">
+              <a14:hiddenFill xmlns="" xmlns:a14="http://schemas.microsoft.com/office/drawing/2010/main">
                 <a:solidFill>
                   <a:srgbClr val="FFFFFF"/>
                 </a:solidFill>
               </a14:hiddenFill>
             </a:ext>
             <a:ext uri="{91240B29-F687-4f45-9708-019B960494DF}">
-              <a14:hiddenLine xmlns:a14="http://schemas.microsoft.com/office/drawing/2010/main" xmlns="" w="9525">
+              <a14:hiddenLine xmlns="" xmlns:a14="http://schemas.microsoft.com/office/drawing/2010/main" w="9525">
                 <a:solidFill>
                   <a:srgbClr val="000000"/>
                 </a:solidFill>
@@ -15734,7 +15734,7 @@
           </a:ln>
           <a:extLst>
             <a:ext uri="{909E8E84-426E-40dd-AFC4-6F175D3DCCD1}">
-              <a14:hiddenFill xmlns:a14="http://schemas.microsoft.com/office/drawing/2010/main" xmlns="">
+              <a14:hiddenFill xmlns="" xmlns:a14="http://schemas.microsoft.com/office/drawing/2010/main">
                 <a:solidFill>
                   <a:srgbClr val="FFFFFF"/>
                 </a:solidFill>
@@ -17235,14 +17235,14 @@
           </a:ln>
           <a:extLst>
             <a:ext uri="{909E8E84-426E-40dd-AFC4-6F175D3DCCD1}">
-              <a14:hiddenFill xmlns:a14="http://schemas.microsoft.com/office/drawing/2010/main" xmlns="">
+              <a14:hiddenFill xmlns="" xmlns:a14="http://schemas.microsoft.com/office/drawing/2010/main">
                 <a:solidFill>
                   <a:srgbClr val="FFFFFF"/>
                 </a:solidFill>
               </a14:hiddenFill>
             </a:ext>
             <a:ext uri="{91240B29-F687-4f45-9708-019B960494DF}">
-              <a14:hiddenLine xmlns:a14="http://schemas.microsoft.com/office/drawing/2010/main" xmlns="" w="9525">
+              <a14:hiddenLine xmlns="" xmlns:a14="http://schemas.microsoft.com/office/drawing/2010/main" w="9525">
                 <a:solidFill>
                   <a:srgbClr val="000000"/>
                 </a:solidFill>
@@ -21872,14 +21872,14 @@
           </a:ln>
           <a:extLst>
             <a:ext uri="{909E8E84-426E-40dd-AFC4-6F175D3DCCD1}">
-              <a14:hiddenFill xmlns:a14="http://schemas.microsoft.com/office/drawing/2010/main" xmlns="">
+              <a14:hiddenFill xmlns="" xmlns:a14="http://schemas.microsoft.com/office/drawing/2010/main">
                 <a:solidFill>
                   <a:srgbClr val="FFFFFF"/>
                 </a:solidFill>
               </a14:hiddenFill>
             </a:ext>
             <a:ext uri="{91240B29-F687-4f45-9708-019B960494DF}">
-              <a14:hiddenLine xmlns:a14="http://schemas.microsoft.com/office/drawing/2010/main" xmlns="" w="9525">
+              <a14:hiddenLine xmlns="" xmlns:a14="http://schemas.microsoft.com/office/drawing/2010/main" w="9525">
                 <a:solidFill>
                   <a:srgbClr val="000000"/>
                 </a:solidFill>
@@ -22183,14 +22183,14 @@
           </a:ln>
           <a:extLst>
             <a:ext uri="{909E8E84-426E-40dd-AFC4-6F175D3DCCD1}">
-              <a14:hiddenFill xmlns:a14="http://schemas.microsoft.com/office/drawing/2010/main" xmlns="">
+              <a14:hiddenFill xmlns="" xmlns:a14="http://schemas.microsoft.com/office/drawing/2010/main">
                 <a:solidFill>
                   <a:srgbClr val="FFFFFF"/>
                 </a:solidFill>
               </a14:hiddenFill>
             </a:ext>
             <a:ext uri="{91240B29-F687-4f45-9708-019B960494DF}">
-              <a14:hiddenLine xmlns:a14="http://schemas.microsoft.com/office/drawing/2010/main" xmlns="" w="9525">
+              <a14:hiddenLine xmlns="" xmlns:a14="http://schemas.microsoft.com/office/drawing/2010/main" w="9525">
                 <a:solidFill>
                   <a:srgbClr val="000000"/>
                 </a:solidFill>
@@ -22549,7 +22549,7 @@
           </a:ln>
           <a:extLst>
             <a:ext uri="{909E8E84-426E-40dd-AFC4-6F175D3DCCD1}">
-              <a14:hiddenFill xmlns:a14="http://schemas.microsoft.com/office/drawing/2010/main" xmlns="">
+              <a14:hiddenFill xmlns="" xmlns:a14="http://schemas.microsoft.com/office/drawing/2010/main">
                 <a:noFill/>
               </a14:hiddenFill>
             </a:ext>
@@ -22590,7 +22590,7 @@
           </a:ln>
           <a:extLst>
             <a:ext uri="{909E8E84-426E-40dd-AFC4-6F175D3DCCD1}">
-              <a14:hiddenFill xmlns:a14="http://schemas.microsoft.com/office/drawing/2010/main" xmlns="">
+              <a14:hiddenFill xmlns="" xmlns:a14="http://schemas.microsoft.com/office/drawing/2010/main">
                 <a:noFill/>
               </a14:hiddenFill>
             </a:ext>
@@ -22633,7 +22633,7 @@
           </a:ln>
           <a:extLst>
             <a:ext uri="{909E8E84-426E-40dd-AFC4-6F175D3DCCD1}">
-              <a14:hiddenFill xmlns:a14="http://schemas.microsoft.com/office/drawing/2010/main" xmlns="">
+              <a14:hiddenFill xmlns="" xmlns:a14="http://schemas.microsoft.com/office/drawing/2010/main">
                 <a:solidFill>
                   <a:srgbClr val="FFFFFF"/>
                 </a:solidFill>
@@ -22793,7 +22793,7 @@
           </a:ln>
           <a:extLst>
             <a:ext uri="{909E8E84-426E-40dd-AFC4-6F175D3DCCD1}">
-              <a14:hiddenFill xmlns:a14="http://schemas.microsoft.com/office/drawing/2010/main" xmlns="">
+              <a14:hiddenFill xmlns="" xmlns:a14="http://schemas.microsoft.com/office/drawing/2010/main">
                 <a:solidFill>
                   <a:srgbClr val="FFFFFF"/>
                 </a:solidFill>

</xml_diff>